<commit_message>
Refresh 5 carrusel covers to photo-duotono
</commit_message>
<xml_diff>
--- a/Dia-15/Carrusel Ranking Tiers - FB 1080x1080.pptx
+++ b/Dia-15/Carrusel Ranking Tiers - FB 1080x1080.pptx
@@ -3087,7 +3087,7 @@
     <p:bg>
       <p:bgPr>
         <a:solidFill>
-          <a:srgbClr val="F5C13F"/>
+          <a:srgbClr val="14181F"/>
         </a:solidFill>
         <a:effectLst/>
       </p:bgPr>
@@ -3099,9 +3099,33 @@
         <p:nvPr/>
       </p:nvGrpSpPr>
       <p:grpSpPr/>
-      <p:sp>
-        <p:nvSpPr>
-          <p:cNvPr id="2" name="Rounded Rectangle 1"/>
+      <p:pic>
+        <p:nvPicPr>
+          <p:cNvPr id="2" name="Picture 1" descr="A_11_duo.png"/>
+          <p:cNvPicPr>
+            <a:picLocks noChangeAspect="1"/>
+          </p:cNvPicPr>
+          <p:nvPr/>
+        </p:nvPicPr>
+        <p:blipFill>
+          <a:blip r:embed="rId2"/>
+          <a:stretch>
+            <a:fillRect/>
+          </a:stretch>
+        </p:blipFill>
+        <p:spPr>
+          <a:xfrm>
+            <a:off x="0" y="0"/>
+            <a:ext cx="8229600" cy="8229600"/>
+          </a:xfrm>
+          <a:prstGeom prst="rect">
+            <a:avLst/>
+          </a:prstGeom>
+        </p:spPr>
+      </p:pic>
+      <p:sp>
+        <p:nvSpPr>
+          <p:cNvPr id="3" name="Rounded Rectangle 2"/>
           <p:cNvSpPr/>
           <p:nvPr/>
         </p:nvSpPr>
@@ -3116,7 +3140,7 @@
             </a:avLst>
           </a:prstGeom>
           <a:solidFill>
-            <a:srgbClr val="14181F"/>
+            <a:srgbClr val="F5C13F"/>
           </a:solidFill>
           <a:ln>
             <a:noFill/>
@@ -3145,7 +3169,7 @@
             <a:r>
               <a:rPr sz="1500" b="1">
                 <a:solidFill>
-                  <a:srgbClr val="F5C13F"/>
+                  <a:srgbClr val="14181F"/>
                 </a:solidFill>
                 <a:latin typeface="Bricolage Grotesque"/>
               </a:rPr>
@@ -3156,58 +3180,14 @@
       </p:sp>
       <p:sp>
         <p:nvSpPr>
-          <p:cNvPr id="3" name="Rectangle 2"/>
-          <p:cNvSpPr/>
-          <p:nvPr/>
-        </p:nvSpPr>
-        <p:spPr>
-          <a:xfrm>
-            <a:off x="777240" y="1764411"/>
-            <a:ext cx="1371600" cy="146304"/>
-          </a:xfrm>
-          <a:prstGeom prst="rect">
-            <a:avLst/>
-          </a:prstGeom>
-          <a:solidFill>
-            <a:srgbClr val="14181F"/>
-          </a:solidFill>
-          <a:ln>
-            <a:noFill/>
-          </a:ln>
-          <a:effectLst/>
-        </p:spPr>
-        <p:style>
-          <a:lnRef idx="1">
-            <a:schemeClr val="accent1"/>
-          </a:lnRef>
-          <a:fillRef idx="3">
-            <a:schemeClr val="accent1"/>
-          </a:fillRef>
-          <a:effectRef idx="2">
-            <a:schemeClr val="accent1"/>
-          </a:effectRef>
-          <a:fontRef idx="minor">
-            <a:schemeClr val="lt1"/>
-          </a:fontRef>
-        </p:style>
-        <p:txBody>
-          <a:bodyPr rtlCol="0" anchor="ctr"/>
-          <a:lstStyle/>
-          <a:p>
-            <a:pPr algn="ctr"/>
-          </a:p>
-        </p:txBody>
-      </p:sp>
-      <p:sp>
-        <p:nvSpPr>
           <p:cNvPr id="4" name="TextBox 3"/>
           <p:cNvSpPr txBox="1"/>
           <p:nvPr/>
         </p:nvSpPr>
         <p:spPr>
           <a:xfrm>
-            <a:off x="777240" y="2221611"/>
-            <a:ext cx="6675120" cy="3054858"/>
+            <a:off x="777240" y="1435608"/>
+            <a:ext cx="6675120" cy="2864358"/>
           </a:xfrm>
           <a:prstGeom prst="rect">
             <a:avLst/>
@@ -3226,9 +3206,9 @@
               </a:lnSpc>
             </a:pPr>
             <a:r>
-              <a:rPr sz="5800" b="1">
+              <a:rPr sz="5400" b="1">
                 <a:solidFill>
-                  <a:srgbClr val="14181F"/>
+                  <a:srgbClr val="FFFFFF"/>
                 </a:solidFill>
                 <a:latin typeface="Bricolage Grotesque"/>
               </a:rPr>
@@ -3245,8 +3225,8 @@
         </p:nvSpPr>
         <p:spPr>
           <a:xfrm>
-            <a:off x="777240" y="5276469"/>
-            <a:ext cx="6675120" cy="1118108"/>
+            <a:off x="777240" y="4299966"/>
+            <a:ext cx="6675120" cy="835660"/>
           </a:xfrm>
           <a:prstGeom prst="rect">
             <a:avLst/>
@@ -3265,9 +3245,9 @@
               </a:lnSpc>
             </a:pPr>
             <a:r>
-              <a:rPr sz="2600" b="0">
+              <a:rPr sz="2200" b="0">
                 <a:solidFill>
-                  <a:srgbClr val="14181F"/>
+                  <a:srgbClr val="FFFFFF"/>
                 </a:solidFill>
                 <a:latin typeface="Hanken Grotesk"/>
               </a:rPr>
@@ -3306,7 +3286,7 @@
             <a:r>
               <a:rPr sz="1800" b="1">
                 <a:solidFill>
-                  <a:srgbClr val="14181F"/>
+                  <a:srgbClr val="F5C13F"/>
                 </a:solidFill>
                 <a:latin typeface="Bricolage Grotesque"/>
               </a:rPr>
@@ -3315,7 +3295,7 @@
             <a:r>
               <a:rPr sz="1800" b="1">
                 <a:solidFill>
-                  <a:srgbClr val="14181F"/>
+                  <a:srgbClr val="FFFFFF"/>
                 </a:solidFill>
                 <a:latin typeface="Bricolage Grotesque"/>
               </a:rPr>
@@ -3354,7 +3334,7 @@
             <a:r>
               <a:rPr sz="2000" b="1">
                 <a:solidFill>
-                  <a:srgbClr val="14181F"/>
+                  <a:srgbClr val="FFFFFF"/>
                 </a:solidFill>
                 <a:latin typeface="Bricolage Grotesque"/>
               </a:rPr>

</xml_diff>